<commit_message>
Add demo video URL to slides
</commit_message>
<xml_diff>
--- a/reports/Weather_Trend_Forecasting.pptx
+++ b/reports/Weather_Trend_Forecasting.pptx
@@ -5935,38 +5935,26 @@
           </a:bodyPr>
           <a:lstStyle/>
           <a:p>
-            <a:pPr algn="l">
+            <a:pPr>
               <a:spcAft>
                 <a:spcPts val="600"/>
               </a:spcAft>
             </a:pPr>
             <a:r>
-              <a:rPr sz="1800" b="0" i="0" dirty="0">
+              <a:rPr lang="en-US" dirty="0">
                 <a:solidFill>
                   <a:srgbClr val="0E4D64"/>
                 </a:solidFill>
                 <a:latin typeface="Consolas"/>
               </a:rPr>
-              <a:t>[video-</a:t>
-            </a:r>
-            <a:r>
-              <a:rPr sz="1800" b="0" i="0" dirty="0" err="1">
-                <a:solidFill>
-                  <a:srgbClr val="0E4D64"/>
-                </a:solidFill>
-                <a:latin typeface="Consolas"/>
-              </a:rPr>
-              <a:t>url</a:t>
-            </a:r>
-            <a:r>
-              <a:rPr sz="1800" b="0" i="0" dirty="0">
-                <a:solidFill>
-                  <a:srgbClr val="0E4D64"/>
-                </a:solidFill>
-                <a:latin typeface="Consolas"/>
-              </a:rPr>
-              <a:t>]</a:t>
-            </a:r>
+              <a:t>https://youtu.be/1ZwhvgLowmE</a:t>
+            </a:r>
+            <a:endParaRPr sz="1800" b="0" i="0" dirty="0">
+              <a:solidFill>
+                <a:srgbClr val="0E4D64"/>
+              </a:solidFill>
+              <a:latin typeface="Consolas"/>
+            </a:endParaRPr>
           </a:p>
         </p:txBody>
       </p:sp>

</xml_diff>